<commit_message>
Add Team Nexon and Amrita Vishwa Vidyapeetham details
</commit_message>
<xml_diff>
--- a/docs/VitalTwin_Presentation.pptx
+++ b/docs/VitalTwin_Presentation.pptx
@@ -3287,7 +3287,7 @@
                 </a:solidFill>
                 <a:latin typeface="Segoe UI"/>
               </a:rPr>
-              <a:t>Team: [Team name]</a:t>
+              <a:t>Team: Nexon</a:t>
             </a:r>
           </a:p>
           <a:p>
@@ -3299,7 +3299,7 @@
                 </a:solidFill>
                 <a:latin typeface="Segoe UI"/>
               </a:rPr>
-              <a:t>Members: [Member 1], [Member 2], [Member 3]</a:t>
+              <a:t>Members: Anushree Kasturi</a:t>
             </a:r>
           </a:p>
           <a:p>
@@ -3311,7 +3311,7 @@
                 </a:solidFill>
                 <a:latin typeface="Segoe UI"/>
               </a:rPr>
-              <a:t>Institution: [College / Incubator name, City]</a:t>
+              <a:t>Institution: Amrita Vishwa Vidyapeetham, Bengaluru</a:t>
             </a:r>
           </a:p>
         </p:txBody>
@@ -5001,7 +5001,7 @@
                 </a:solidFill>
                 <a:latin typeface="Segoe UI"/>
               </a:rPr>
-              <a:t>Team: [Team name]</a:t>
+              <a:t>Team: Nexon</a:t>
             </a:r>
           </a:p>
           <a:p>
@@ -5013,7 +5013,7 @@
                 </a:solidFill>
                 <a:latin typeface="Segoe UI"/>
               </a:rPr>
-              <a:t>Members: [Member 1], [Member 2], [Member 3]</a:t>
+              <a:t>Members: Anushree Kasturi</a:t>
             </a:r>
           </a:p>
           <a:p>
@@ -5025,7 +5025,7 @@
                 </a:solidFill>
                 <a:latin typeface="Segoe UI"/>
               </a:rPr>
-              <a:t>Institution: [College / Incubator name, City]</a:t>
+              <a:t>Institution: Amrita Vishwa Vidyapeetham, Bengaluru</a:t>
             </a:r>
           </a:p>
           <a:p>

</xml_diff>

<commit_message>
Add live demo link (vitaltwin.streamlit.app)
</commit_message>
<xml_diff>
--- a/docs/VitalTwin_Presentation.pptx
+++ b/docs/VitalTwin_Presentation.pptx
@@ -3314,6 +3314,30 @@
               <a:t>Institution: Amrita Vishwa Vidyapeetham, Bengaluru</a:t>
             </a:r>
           </a:p>
+          <a:p>
+            <a:pPr algn="l"/>
+            <a:r>
+              <a:rPr sz="1600" b="0">
+                <a:solidFill>
+                  <a:srgbClr val="0B0B0B"/>
+                </a:solidFill>
+                <a:latin typeface="Segoe UI"/>
+              </a:rPr>
+              <a:t/>
+            </a:r>
+          </a:p>
+          <a:p>
+            <a:pPr algn="l"/>
+            <a:r>
+              <a:rPr sz="1600" b="0">
+                <a:solidFill>
+                  <a:srgbClr val="0B0B0B"/>
+                </a:solidFill>
+                <a:latin typeface="Segoe UI"/>
+              </a:rPr>
+              <a:t>Live demo: https://vitaltwin.streamlit.app/</a:t>
+            </a:r>
+          </a:p>
         </p:txBody>
       </p:sp>
     </p:spTree>
@@ -5038,6 +5062,18 @@
                 <a:latin typeface="Segoe UI"/>
               </a:rPr>
               <a:t/>
+            </a:r>
+          </a:p>
+          <a:p>
+            <a:pPr algn="l"/>
+            <a:r>
+              <a:rPr sz="1800" b="0">
+                <a:solidFill>
+                  <a:srgbClr val="0B0B0B"/>
+                </a:solidFill>
+                <a:latin typeface="Segoe UI"/>
+              </a:rPr>
+              <a:t>Live demo: https://vitaltwin.streamlit.app/</a:t>
             </a:r>
           </a:p>
           <a:p>

</xml_diff>